<commit_message>
Finalize reproducible submission and runnable demos
</commit_message>
<xml_diff>
--- a/presentations/insy684-mlops-technical-section.pptx
+++ b/presentations/insy684-mlops-technical-section.pptx
@@ -2,23 +2,23 @@
 <file path=ppt/presentation.xml><?xml version="1.0" encoding="utf-8"?>
 <p:presentation xmlns:p="http://schemas.openxmlformats.org/presentationml/2006/main">
   <p:sldMasterIdLst>
-    <p:sldMasterId xmlns:r="http://schemas.openxmlformats.org/officeDocument/2006/relationships" id="2147483648" r:id="Rbe1e5fc5f34e4697"/>
+    <p:sldMasterId xmlns:r="http://schemas.openxmlformats.org/officeDocument/2006/relationships" id="2147483648" r:id="R7d910a14a3e3431e"/>
   </p:sldMasterIdLst>
   <p:notesMasterIdLst>
-    <p:notesMasterId xmlns:r="http://schemas.openxmlformats.org/officeDocument/2006/relationships" r:id="R804a838f977b4008"/>
+    <p:notesMasterId xmlns:r="http://schemas.openxmlformats.org/officeDocument/2006/relationships" r:id="Rb3c60301405045c5"/>
   </p:notesMasterIdLst>
   <p:sldIdLst>
-    <p:sldId xmlns:r="http://schemas.openxmlformats.org/officeDocument/2006/relationships" id="256" r:id="R0e691822c7a14e67"/>
-    <p:sldId xmlns:r="http://schemas.openxmlformats.org/officeDocument/2006/relationships" id="257" r:id="R0d1cde76c6e44215"/>
-    <p:sldId xmlns:r="http://schemas.openxmlformats.org/officeDocument/2006/relationships" id="258" r:id="Rd0a34c15f3f74da6"/>
-    <p:sldId xmlns:r="http://schemas.openxmlformats.org/officeDocument/2006/relationships" id="259" r:id="Rf4b16f4b66d84832"/>
-    <p:sldId xmlns:r="http://schemas.openxmlformats.org/officeDocument/2006/relationships" id="260" r:id="R731c746232ef48cd"/>
-    <p:sldId xmlns:r="http://schemas.openxmlformats.org/officeDocument/2006/relationships" id="261" r:id="Rc5606795cdef4944"/>
-    <p:sldId xmlns:r="http://schemas.openxmlformats.org/officeDocument/2006/relationships" id="262" r:id="Rda1b86a3ff9d4ecb"/>
-    <p:sldId xmlns:r="http://schemas.openxmlformats.org/officeDocument/2006/relationships" id="263" r:id="R77fd46cf86834cc2"/>
-    <p:sldId xmlns:r="http://schemas.openxmlformats.org/officeDocument/2006/relationships" id="264" r:id="R1f79c3f175d54be0"/>
-    <p:sldId xmlns:r="http://schemas.openxmlformats.org/officeDocument/2006/relationships" id="265" r:id="Ra59078b789ab4d89"/>
-    <p:sldId xmlns:r="http://schemas.openxmlformats.org/officeDocument/2006/relationships" id="266" r:id="R52bb7b2cb5ec48ad"/>
+    <p:sldId xmlns:r="http://schemas.openxmlformats.org/officeDocument/2006/relationships" id="256" r:id="R5cd266fd67b54597"/>
+    <p:sldId xmlns:r="http://schemas.openxmlformats.org/officeDocument/2006/relationships" id="257" r:id="R87008bfe62a44728"/>
+    <p:sldId xmlns:r="http://schemas.openxmlformats.org/officeDocument/2006/relationships" id="258" r:id="Redba5eceb451462c"/>
+    <p:sldId xmlns:r="http://schemas.openxmlformats.org/officeDocument/2006/relationships" id="259" r:id="R5c01959b510643a5"/>
+    <p:sldId xmlns:r="http://schemas.openxmlformats.org/officeDocument/2006/relationships" id="260" r:id="R195d6641bbd74635"/>
+    <p:sldId xmlns:r="http://schemas.openxmlformats.org/officeDocument/2006/relationships" id="261" r:id="R3386d832402b4af9"/>
+    <p:sldId xmlns:r="http://schemas.openxmlformats.org/officeDocument/2006/relationships" id="262" r:id="Rf90a0d72b28a4229"/>
+    <p:sldId xmlns:r="http://schemas.openxmlformats.org/officeDocument/2006/relationships" id="263" r:id="Rbf50c4528d404a5e"/>
+    <p:sldId xmlns:r="http://schemas.openxmlformats.org/officeDocument/2006/relationships" id="264" r:id="R7ca5e38a46bc4999"/>
+    <p:sldId xmlns:r="http://schemas.openxmlformats.org/officeDocument/2006/relationships" id="265" r:id="Rbc78afcb2a6d4c27"/>
+    <p:sldId xmlns:r="http://schemas.openxmlformats.org/officeDocument/2006/relationships" id="266" r:id="R6de3b3d3a5124089"/>
   </p:sldIdLst>
   <p:sldSz cx="12192000" cy="6858000"/>
   <p:notesSz cx="6858000" cy="9144000"/>
@@ -1225,7 +1225,7 @@
   </p:cSld>
   <p:clrMap bg1="lt1" tx1="dk1" bg2="lt2" tx2="dk2" accent1="accent1" accent2="accent2" accent3="accent3" accent4="accent4" accent5="accent5" accent6="accent6" hlink="hlink" folHlink="folHlink"/>
   <p:sldLayoutIdLst>
-    <p:sldLayoutId xmlns:r="http://schemas.openxmlformats.org/officeDocument/2006/relationships" id="2147483649" r:id="Rd7e0a293b1ef4f74"/>
+    <p:sldLayoutId xmlns:r="http://schemas.openxmlformats.org/officeDocument/2006/relationships" id="2147483649" r:id="Rf8a06d5d515a4cd6"/>
   </p:sldLayoutIdLst>
   <p:txStyles>
     <p:titleStyle>
@@ -3656,7 +3656,7 @@
           <p:nvPr/>
         </p:nvPicPr>
         <p:blipFill>
-          <a:blip xmlns:r="http://schemas.openxmlformats.org/officeDocument/2006/relationships" xmlns:a="http://schemas.openxmlformats.org/drawingml/2006/main" r:embed="R5189185580654d7a"/>
+          <a:blip xmlns:r="http://schemas.openxmlformats.org/officeDocument/2006/relationships" xmlns:a="http://schemas.openxmlformats.org/drawingml/2006/main" r:embed="R5167ecf903b04717"/>
           <a:stretch xmlns:a="http://schemas.openxmlformats.org/drawingml/2006/main"/>
         </p:blipFill>
         <p:spPr>
@@ -10945,7 +10945,7 @@
           <p:nvPr/>
         </p:nvPicPr>
         <p:blipFill>
-          <a:blip xmlns:r="http://schemas.openxmlformats.org/officeDocument/2006/relationships" xmlns:a="http://schemas.openxmlformats.org/drawingml/2006/main" r:embed="Rd9036e98163048c0"/>
+          <a:blip xmlns:r="http://schemas.openxmlformats.org/officeDocument/2006/relationships" xmlns:a="http://schemas.openxmlformats.org/drawingml/2006/main" r:embed="Ref0516fb651e4055"/>
           <a:stretch xmlns:a="http://schemas.openxmlformats.org/drawingml/2006/main"/>
         </p:blipFill>
         <p:spPr>
@@ -11779,7 +11779,7 @@
           <p:nvPr/>
         </p:nvPicPr>
         <p:blipFill>
-          <a:blip xmlns:r="http://schemas.openxmlformats.org/officeDocument/2006/relationships" xmlns:a="http://schemas.openxmlformats.org/drawingml/2006/main" r:embed="Raeddb94ca1fa43b7"/>
+          <a:blip xmlns:r="http://schemas.openxmlformats.org/officeDocument/2006/relationships" xmlns:a="http://schemas.openxmlformats.org/drawingml/2006/main" r:embed="R4c67611d7b324280"/>
           <a:stretch xmlns:a="http://schemas.openxmlformats.org/drawingml/2006/main"/>
         </p:blipFill>
         <p:spPr>
@@ -11801,7 +11801,7 @@
           <p:nvPr/>
         </p:nvPicPr>
         <p:blipFill>
-          <a:blip xmlns:r="http://schemas.openxmlformats.org/officeDocument/2006/relationships" xmlns:a="http://schemas.openxmlformats.org/drawingml/2006/main" r:embed="Rf5c3c7b6f59b4751"/>
+          <a:blip xmlns:r="http://schemas.openxmlformats.org/officeDocument/2006/relationships" xmlns:a="http://schemas.openxmlformats.org/drawingml/2006/main" r:embed="R0e1de792c523478d"/>
           <a:stretch xmlns:a="http://schemas.openxmlformats.org/drawingml/2006/main"/>
         </p:blipFill>
         <p:spPr>
@@ -12213,7 +12213,7 @@
           <p:nvPr/>
         </p:nvPicPr>
         <p:blipFill>
-          <a:blip xmlns:r="http://schemas.openxmlformats.org/officeDocument/2006/relationships" xmlns:a="http://schemas.openxmlformats.org/drawingml/2006/main" r:embed="R051b0f9027e84a9a"/>
+          <a:blip xmlns:r="http://schemas.openxmlformats.org/officeDocument/2006/relationships" xmlns:a="http://schemas.openxmlformats.org/drawingml/2006/main" r:embed="Rbcacbbb75955482a"/>
           <a:stretch xmlns:a="http://schemas.openxmlformats.org/drawingml/2006/main"/>
         </p:blipFill>
         <p:spPr>
@@ -12657,7 +12657,7 @@
           <p:nvPr/>
         </p:nvPicPr>
         <p:blipFill>
-          <a:blip xmlns:r="http://schemas.openxmlformats.org/officeDocument/2006/relationships" xmlns:a="http://schemas.openxmlformats.org/drawingml/2006/main" r:embed="R917f079178364f53"/>
+          <a:blip xmlns:r="http://schemas.openxmlformats.org/officeDocument/2006/relationships" xmlns:a="http://schemas.openxmlformats.org/drawingml/2006/main" r:embed="R4908a5f20fc04873"/>
           <a:stretch xmlns:a="http://schemas.openxmlformats.org/drawingml/2006/main"/>
         </p:blipFill>
         <p:spPr>

</xml_diff>